<commit_message>
Add real-photo generalization test on CNRPark-EXT; remove dead node build scripts
Tests the synthetic-trained detector against 115 real, full-scene CNRPark-EXT
photos (real_photo_test.py streams a small partial download, no 450MB archive
needed). Finding: coarse car-cluster signal transfers, precise localization
and the empty_spot class do not -- consistent with this project's earlier 40%
cross-domain result for the classifier pipeline on the same dataset. Folded
into the report and slides so the real-world validation gap is a measured
result, not an open unknown.

Also removes build_report.js/build_slides.js (node-based, non-functional
without node in this environment, fully superseded by the python
build_report_docx.py / build_slides_pptx.py equivalents).
</commit_message>
<xml_diff>
--- a/smartpark/report_assets/SmartPark_Slides.pptx
+++ b/smartpark/report_assets/SmartPark_Slides.pptx
@@ -21,6 +21,7 @@
     <p:sldId id="269" r:id="rId20"/>
     <p:sldId id="270" r:id="rId21"/>
     <p:sldId id="271" r:id="rId22"/>
+    <p:sldId id="272" r:id="rId23"/>
   </p:sldIdLst>
   <p:sldSz cx="12188952" cy="6858000" type="screen4x3"/>
   <p:notesSz cx="6858000" cy="9144000"/>
@@ -4772,7 +4773,7 @@
                 </a:solidFill>
                 <a:latin typeface="Calibri"/>
               </a:rPr>
-              <a:t>Discussion &amp; Limitations</a:t>
+              <a:t>Real-Photo Generalization Test</a:t>
             </a:r>
           </a:p>
         </p:txBody>
@@ -4807,21 +4808,45 @@
                 </a:solidFill>
                 <a:latin typeface="Calibri"/>
               </a:rPr>
-              <a:t>Honest accounting</a:t>
-            </a:r>
-          </a:p>
-        </p:txBody>
-      </p:sp>
-      <p:sp>
-        <p:nvSpPr>
-          <p:cNvPr id="5" name="TextBox 4"/>
+              <a:t>Qualitative — trained only on synthetic data, run on real CNRPark-EXT photos</a:t>
+            </a:r>
+          </a:p>
+        </p:txBody>
+      </p:sp>
+      <p:pic>
+        <p:nvPicPr>
+          <p:cNvPr id="5" name="Picture 4" descr="example_2.jpg"/>
+          <p:cNvPicPr>
+            <a:picLocks noChangeAspect="1"/>
+          </p:cNvPicPr>
+          <p:nvPr/>
+        </p:nvPicPr>
+        <p:blipFill>
+          <a:blip r:embed="rId2"/>
+          <a:stretch>
+            <a:fillRect/>
+          </a:stretch>
+        </p:blipFill>
+        <p:spPr>
+          <a:xfrm>
+            <a:off x="1097280" y="1668780"/>
+            <a:ext cx="6035040" cy="4526280"/>
+          </a:xfrm>
+          <a:prstGeom prst="rect">
+            <a:avLst/>
+          </a:prstGeom>
+        </p:spPr>
+      </p:pic>
+      <p:sp>
+        <p:nvSpPr>
+          <p:cNvPr id="6" name="TextBox 5"/>
           <p:cNvSpPr txBox="1"/>
           <p:nvPr/>
         </p:nvSpPr>
         <p:spPr>
           <a:xfrm>
-            <a:off x="640080" y="1737360"/>
-            <a:ext cx="10698480" cy="4389120"/>
+            <a:off x="7406640" y="1828800"/>
+            <a:ext cx="4206240" cy="4114800"/>
           </a:xfrm>
           <a:prstGeom prst="rect">
             <a:avLst/>
@@ -4838,14 +4863,14 @@
               <a:spcAft>
                 <a:spcPts val="800"/>
               </a:spcAft>
-              <a:defRPr sz="1700">
+              <a:defRPr sz="1400">
                 <a:solidFill>
                   <a:srgbClr val="F4F4F5"/>
                 </a:solidFill>
               </a:defRPr>
             </a:pPr>
             <a:r>
-              <a:t>•  Worked: staged synthetic-first build let the whole pipeline be validated cheaply before real data</a:t>
+              <a:t>•  115 real photos tested, no painted lines, steep real camera angle</a:t>
             </a:r>
           </a:p>
           <a:p>
@@ -4853,14 +4878,14 @@
               <a:spcAft>
                 <a:spcPts val="800"/>
               </a:spcAft>
-              <a:defRPr sz="1700">
+              <a:defRPr sz="1400">
                 <a:solidFill>
                   <a:srgbClr val="F4F4F5"/>
                 </a:solidFill>
               </a:defRPr>
             </a:pPr>
             <a:r>
-              <a:t>•  Had to be revisited: the original classifier-only version didn't satisfy Object Detection — only caught by auditing against the rubric, requiring a genuine architecture change in Sprint 4</a:t>
+              <a:t>•  Boxes loosely cluster near real cars — some transferable signal</a:t>
             </a:r>
           </a:p>
           <a:p>
@@ -4868,14 +4893,14 @@
               <a:spcAft>
                 <a:spcPts val="800"/>
               </a:spcAft>
-              <a:defRPr sz="1700">
+              <a:defRPr sz="1400">
                 <a:solidFill>
                   <a:srgbClr val="F4F4F5"/>
                 </a:solidFill>
               </a:defRPr>
             </a:pPr>
             <a:r>
-              <a:t>•  Detector is validated on synthetic data only — real photos (shadows, lighting, dense packing) remain the main open validation gap; the classifier's real-PKLot result doesn't cover the detector</a:t>
+              <a:t>•  Misses most vehicles; box shapes imprecise</a:t>
             </a:r>
           </a:p>
           <a:p>
@@ -4883,14 +4908,29 @@
               <a:spcAft>
                 <a:spcPts val="800"/>
               </a:spcAft>
-              <a:defRPr sz="1700">
+              <a:defRPr sz="1400">
                 <a:solidFill>
                   <a:srgbClr val="F4F4F5"/>
                 </a:solidFill>
               </a:defRPr>
             </a:pPr>
             <a:r>
-              <a:t>•  Low-contrast cars (e.g. gray-on-gray) are the concentrated failure mode, in both the new detector and the original classic-CV heuristic — the clear next target</a:t>
+              <a:t>•  empty_spot almost never fires — no painted bays in this domain</a:t>
+            </a:r>
+          </a:p>
+          <a:p>
+            <a:pPr>
+              <a:spcAft>
+                <a:spcPts val="800"/>
+              </a:spcAft>
+              <a:defRPr sz="1400">
+                <a:solidFill>
+                  <a:srgbClr val="F4F4F5"/>
+                </a:solidFill>
+              </a:defRPr>
+            </a:pPr>
+            <a:r>
+              <a:t>•  Matches this project's earlier classifier result: 40% on the same cross-domain test</a:t>
             </a:r>
           </a:p>
         </p:txBody>
@@ -4987,7 +5027,7 @@
                 </a:solidFill>
                 <a:latin typeface="Calibri"/>
               </a:rPr>
-              <a:t>Conclusion</a:t>
+              <a:t>Discussion &amp; Limitations</a:t>
             </a:r>
           </a:p>
         </p:txBody>
@@ -5000,8 +5040,8 @@
         </p:nvSpPr>
         <p:spPr>
           <a:xfrm>
-            <a:off x="731520" y="2011680"/>
-            <a:ext cx="10698480" cy="3657600"/>
+            <a:off x="548640" y="960120"/>
+            <a:ext cx="10972800" cy="457200"/>
           </a:xfrm>
           <a:prstGeom prst="rect">
             <a:avLst/>
@@ -5016,13 +5056,96 @@
           <a:p>
             <a:pPr algn="l"/>
             <a:r>
-              <a:rPr sz="2000" b="0">
+              <a:rPr sz="1500" b="0">
+                <a:solidFill>
+                  <a:srgbClr val="A1A1AA"/>
+                </a:solidFill>
+                <a:latin typeface="Calibri"/>
+              </a:rPr>
+              <a:t>Honest accounting</a:t>
+            </a:r>
+          </a:p>
+        </p:txBody>
+      </p:sp>
+      <p:sp>
+        <p:nvSpPr>
+          <p:cNvPr id="5" name="TextBox 4"/>
+          <p:cNvSpPr txBox="1"/>
+          <p:nvPr/>
+        </p:nvSpPr>
+        <p:spPr>
+          <a:xfrm>
+            <a:off x="640080" y="1737360"/>
+            <a:ext cx="10698480" cy="4389120"/>
+          </a:xfrm>
+          <a:prstGeom prst="rect">
+            <a:avLst/>
+          </a:prstGeom>
+          <a:noFill/>
+        </p:spPr>
+        <p:txBody>
+          <a:bodyPr wrap="square">
+            <a:spAutoFit/>
+          </a:bodyPr>
+          <a:lstStyle/>
+          <a:p>
+            <a:pPr>
+              <a:spcAft>
+                <a:spcPts val="800"/>
+              </a:spcAft>
+              <a:defRPr sz="1700">
                 <a:solidFill>
                   <a:srgbClr val="F4F4F5"/>
                 </a:solidFill>
-                <a:latin typeface="Calibri"/>
-              </a:rPr>
-              <a:t>A from-scratch object detector for two classes (empty_spot / occupied_spot), 98.71% mAP@0.5, beating both a majority-class baseline (53.3%) and this project's own earlier classic-CV heuristic (82.7%). Served live through a REST API and browser demo, alongside a real-data-validated occupancy classifier for calibrated cameras. Main next step: validate the detector on real, non-synthetic photographs.</a:t>
+              </a:defRPr>
+            </a:pPr>
+            <a:r>
+              <a:t>•  Worked: staged synthetic-first build let the whole pipeline be validated cheaply before real data</a:t>
+            </a:r>
+          </a:p>
+          <a:p>
+            <a:pPr>
+              <a:spcAft>
+                <a:spcPts val="800"/>
+              </a:spcAft>
+              <a:defRPr sz="1700">
+                <a:solidFill>
+                  <a:srgbClr val="F4F4F5"/>
+                </a:solidFill>
+              </a:defRPr>
+            </a:pPr>
+            <a:r>
+              <a:t>•  Had to be revisited: the original classifier-only version didn't satisfy Object Detection — only caught by auditing against the rubric, requiring a genuine architecture change in Sprint 4</a:t>
+            </a:r>
+          </a:p>
+          <a:p>
+            <a:pPr>
+              <a:spcAft>
+                <a:spcPts val="800"/>
+              </a:spcAft>
+              <a:defRPr sz="1700">
+                <a:solidFill>
+                  <a:srgbClr val="F4F4F5"/>
+                </a:solidFill>
+              </a:defRPr>
+            </a:pPr>
+            <a:r>
+              <a:t>•  Tested on real photos (CNRPark-EXT): coarse signal transfers, precise localization does not — a real, measured domain gap, not an unexamined unknown</a:t>
+            </a:r>
+          </a:p>
+          <a:p>
+            <a:pPr>
+              <a:spcAft>
+                <a:spcPts val="800"/>
+              </a:spcAft>
+              <a:defRPr sz="1700">
+                <a:solidFill>
+                  <a:srgbClr val="F4F4F5"/>
+                </a:solidFill>
+              </a:defRPr>
+            </a:pPr>
+            <a:r>
+              <a:t>•  Low-contrast cars (e.g. gray-on-gray) are a concentrated failure mode, in both the new detector and the original classic-CV heuristic — the clear next target</a:t>
             </a:r>
           </a:p>
         </p:txBody>
@@ -5036,6 +5159,138 @@
 </file>
 
 <file path=ppt/slides/slide16.xml><?xml version="1.0" encoding="utf-8"?>
+<p:sld xmlns:a="http://schemas.openxmlformats.org/drawingml/2006/main" xmlns:p="http://schemas.openxmlformats.org/presentationml/2006/main" xmlns:r="http://schemas.openxmlformats.org/officeDocument/2006/relationships">
+  <p:cSld>
+    <p:spTree>
+      <p:nvGrpSpPr>
+        <p:cNvPr id="1" name=""/>
+        <p:cNvGrpSpPr/>
+        <p:nvPr/>
+      </p:nvGrpSpPr>
+      <p:grpSpPr/>
+      <p:sp>
+        <p:nvSpPr>
+          <p:cNvPr id="2" name="Rectangle 1"/>
+          <p:cNvSpPr/>
+          <p:nvPr/>
+        </p:nvSpPr>
+        <p:spPr>
+          <a:xfrm>
+            <a:off x="0" y="0"/>
+            <a:ext cx="12188952" cy="6858000"/>
+          </a:xfrm>
+          <a:prstGeom prst="rect">
+            <a:avLst/>
+          </a:prstGeom>
+          <a:solidFill>
+            <a:srgbClr val="18181B"/>
+          </a:solidFill>
+          <a:ln>
+            <a:noFill/>
+          </a:ln>
+          <a:effectLst/>
+        </p:spPr>
+        <p:style>
+          <a:lnRef idx="1">
+            <a:schemeClr val="accent1"/>
+          </a:lnRef>
+          <a:fillRef idx="3">
+            <a:schemeClr val="accent1"/>
+          </a:fillRef>
+          <a:effectRef idx="2">
+            <a:schemeClr val="accent1"/>
+          </a:effectRef>
+          <a:fontRef idx="minor">
+            <a:schemeClr val="lt1"/>
+          </a:fontRef>
+        </p:style>
+        <p:txBody>
+          <a:bodyPr rtlCol="0" anchor="ctr"/>
+          <a:lstStyle/>
+          <a:p>
+            <a:pPr algn="ctr"/>
+          </a:p>
+        </p:txBody>
+      </p:sp>
+      <p:sp>
+        <p:nvSpPr>
+          <p:cNvPr id="3" name="TextBox 2"/>
+          <p:cNvSpPr txBox="1"/>
+          <p:nvPr/>
+        </p:nvSpPr>
+        <p:spPr>
+          <a:xfrm>
+            <a:off x="548640" y="320040"/>
+            <a:ext cx="10972800" cy="731520"/>
+          </a:xfrm>
+          <a:prstGeom prst="rect">
+            <a:avLst/>
+          </a:prstGeom>
+          <a:noFill/>
+        </p:spPr>
+        <p:txBody>
+          <a:bodyPr wrap="square">
+            <a:spAutoFit/>
+          </a:bodyPr>
+          <a:lstStyle/>
+          <a:p>
+            <a:pPr algn="l"/>
+            <a:r>
+              <a:rPr sz="3000" b="1">
+                <a:solidFill>
+                  <a:srgbClr val="6B8AFF"/>
+                </a:solidFill>
+                <a:latin typeface="Calibri"/>
+              </a:rPr>
+              <a:t>Conclusion</a:t>
+            </a:r>
+          </a:p>
+        </p:txBody>
+      </p:sp>
+      <p:sp>
+        <p:nvSpPr>
+          <p:cNvPr id="4" name="TextBox 3"/>
+          <p:cNvSpPr txBox="1"/>
+          <p:nvPr/>
+        </p:nvSpPr>
+        <p:spPr>
+          <a:xfrm>
+            <a:off x="731520" y="2011680"/>
+            <a:ext cx="10698480" cy="3657600"/>
+          </a:xfrm>
+          <a:prstGeom prst="rect">
+            <a:avLst/>
+          </a:prstGeom>
+          <a:noFill/>
+        </p:spPr>
+        <p:txBody>
+          <a:bodyPr wrap="square">
+            <a:spAutoFit/>
+          </a:bodyPr>
+          <a:lstStyle/>
+          <a:p>
+            <a:pPr algn="l"/>
+            <a:r>
+              <a:rPr sz="1900" b="0">
+                <a:solidFill>
+                  <a:srgbClr val="F4F4F5"/>
+                </a:solidFill>
+                <a:latin typeface="Calibri"/>
+              </a:rPr>
+              <a:t>A from-scratch object detector for two classes (empty_spot / occupied_spot), 98.71% mAP@0.5, beating both a majority-class baseline (53.3%) and this project's own earlier classic-CV heuristic (82.7%). Served live through a REST API and browser demo, alongside a real-data-validated occupancy classifier for calibrated cameras. A real-photo test shows the next step clearly: fine-tune on the target camera's actual images before deployment.</a:t>
+            </a:r>
+          </a:p>
+        </p:txBody>
+      </p:sp>
+    </p:spTree>
+  </p:cSld>
+  <p:clrMapOvr>
+    <a:masterClrMapping/>
+  </p:clrMapOvr>
+</p:sld>
+</file>
+
+<file path=ppt/slides/slide17.xml><?xml version="1.0" encoding="utf-8"?>
 <p:sld xmlns:a="http://schemas.openxmlformats.org/drawingml/2006/main" xmlns:p="http://schemas.openxmlformats.org/presentationml/2006/main" xmlns:r="http://schemas.openxmlformats.org/officeDocument/2006/relationships">
   <p:cSld>
     <p:spTree>

</xml_diff>